<commit_message>
docs(level-4): add Level 4 Waxing Gibbous checklist, Product X profile, and building in public details
</commit_message>
<xml_diff>
--- a/MidnightGate_Presentation.pptx
+++ b/MidnightGate_Presentation.pptx
@@ -4605,6 +4605,18 @@
             </a:pPr>
             <a:r>
               <a:t>✅ APPROVED | Level 3: First Quarter: CI/CD Pipeline + 4/4 Vitest Tests + Approved Idea Proposal</a:t>
+            </a:r>
+          </a:p>
+          <a:p>
+            <a:pPr>
+              <a:defRPr sz="1300">
+                <a:solidFill>
+                  <a:srgbClr val="F3F4F6"/>
+                </a:solidFill>
+              </a:defRPr>
+            </a:pPr>
+            <a:r>
+              <a:t>✅ APPROVED | Level 4: Waxing Gibbous: Working Preprod MVP + Product X Profile (@MidnightGateZK)</a:t>
             </a:r>
           </a:p>
           <a:p>

</xml_diff>